<commit_message>
Requester guide: remove constructs PowerPoint repairs away
Image drop-shadows and type:none fills/lines replaced with transparent
fills and omitted lines - the deck now opens clean without the repair
prompt.

Co-Authored-By: Claude Fable 5 <noreply@anthropic.com>
</commit_message>
<xml_diff>
--- a/docs/PM-DataCare-Requester-Guide.pptx
+++ b/docs/PM-DataCare-Requester-Guide.pptx
@@ -3184,13 +3184,6 @@
           <a:prstGeom prst="rect">
             <a:avLst/>
           </a:prstGeom>
-          <a:effectLst>
-            <a:outerShdw sx="100000" sy="100000" kx="0" ky="0" algn="bl" rotWithShape="0" blurRad="76200" dist="25400" dir="5400000">
-              <a:srgbClr val="90A8BC">
-                <a:alpha val="35000"/>
-              </a:srgbClr>
-            </a:outerShdw>
-          </a:effectLst>
         </p:spPr>
       </p:pic>
       <p:sp>
@@ -3207,6 +3200,11 @@
           <a:prstGeom prst="RECTANGLE">
             <a:avLst/>
           </a:prstGeom>
+          <a:solidFill>
+            <a:srgbClr val="FFFFFF">
+              <a:alpha val="0"/>
+            </a:srgbClr>
+          </a:solidFill>
           <a:ln w="9525">
             <a:solidFill>
               <a:srgbClr val="C3D4E2"/>
@@ -3231,6 +3229,11 @@
               <a:gd name="adj" fmla="val 6087"/>
             </a:avLst>
           </a:prstGeom>
+          <a:solidFill>
+            <a:srgbClr val="FFFFFF">
+              <a:alpha val="0"/>
+            </a:srgbClr>
+          </a:solidFill>
           <a:ln w="28575">
             <a:solidFill>
               <a:srgbClr val="1E63D6"/>
@@ -3319,6 +3322,11 @@
               <a:gd name="adj" fmla="val 9792"/>
             </a:avLst>
           </a:prstGeom>
+          <a:solidFill>
+            <a:srgbClr val="FFFFFF">
+              <a:alpha val="0"/>
+            </a:srgbClr>
+          </a:solidFill>
           <a:ln w="28575">
             <a:solidFill>
               <a:srgbClr val="1E63D6"/>
@@ -3407,6 +3415,11 @@
               <a:gd name="adj" fmla="val 6087"/>
             </a:avLst>
           </a:prstGeom>
+          <a:solidFill>
+            <a:srgbClr val="FFFFFF">
+              <a:alpha val="0"/>
+            </a:srgbClr>
+          </a:solidFill>
           <a:ln w="28575">
             <a:solidFill>
               <a:srgbClr val="1E63D6"/>
@@ -3969,13 +3982,6 @@
           <a:prstGeom prst="rect">
             <a:avLst/>
           </a:prstGeom>
-          <a:effectLst>
-            <a:outerShdw sx="100000" sy="100000" kx="0" ky="0" algn="bl" rotWithShape="0" blurRad="76200" dist="25400" dir="5400000">
-              <a:srgbClr val="90A8BC">
-                <a:alpha val="35000"/>
-              </a:srgbClr>
-            </a:outerShdw>
-          </a:effectLst>
         </p:spPr>
       </p:pic>
       <p:sp>
@@ -3992,6 +3998,11 @@
           <a:prstGeom prst="RECTANGLE">
             <a:avLst/>
           </a:prstGeom>
+          <a:solidFill>
+            <a:srgbClr val="FFFFFF">
+              <a:alpha val="0"/>
+            </a:srgbClr>
+          </a:solidFill>
           <a:ln w="9525">
             <a:solidFill>
               <a:srgbClr val="C3D4E2"/>
@@ -4016,6 +4027,11 @@
               <a:gd name="adj" fmla="val 9008"/>
             </a:avLst>
           </a:prstGeom>
+          <a:solidFill>
+            <a:srgbClr val="FFFFFF">
+              <a:alpha val="0"/>
+            </a:srgbClr>
+          </a:solidFill>
           <a:ln w="28575">
             <a:solidFill>
               <a:srgbClr val="1E63D6"/>
@@ -4104,6 +4120,11 @@
               <a:gd name="adj" fmla="val 15014"/>
             </a:avLst>
           </a:prstGeom>
+          <a:solidFill>
+            <a:srgbClr val="FFFFFF">
+              <a:alpha val="0"/>
+            </a:srgbClr>
+          </a:solidFill>
           <a:ln w="28575">
             <a:solidFill>
               <a:srgbClr val="1E63D6"/>
@@ -4192,6 +4213,11 @@
               <a:gd name="adj" fmla="val 9792"/>
             </a:avLst>
           </a:prstGeom>
+          <a:solidFill>
+            <a:srgbClr val="FFFFFF">
+              <a:alpha val="0"/>
+            </a:srgbClr>
+          </a:solidFill>
           <a:ln w="28575">
             <a:solidFill>
               <a:srgbClr val="1E63D6"/>
@@ -4754,13 +4780,6 @@
           <a:prstGeom prst="rect">
             <a:avLst/>
           </a:prstGeom>
-          <a:effectLst>
-            <a:outerShdw sx="100000" sy="100000" kx="0" ky="0" algn="bl" rotWithShape="0" blurRad="76200" dist="25400" dir="5400000">
-              <a:srgbClr val="90A8BC">
-                <a:alpha val="35000"/>
-              </a:srgbClr>
-            </a:outerShdw>
-          </a:effectLst>
         </p:spPr>
       </p:pic>
       <p:sp>
@@ -4777,6 +4796,11 @@
           <a:prstGeom prst="RECTANGLE">
             <a:avLst/>
           </a:prstGeom>
+          <a:solidFill>
+            <a:srgbClr val="FFFFFF">
+              <a:alpha val="0"/>
+            </a:srgbClr>
+          </a:solidFill>
           <a:ln w="9525">
             <a:solidFill>
               <a:srgbClr val="C3D4E2"/>
@@ -4801,6 +4825,11 @@
               <a:gd name="adj" fmla="val 10724"/>
             </a:avLst>
           </a:prstGeom>
+          <a:solidFill>
+            <a:srgbClr val="FFFFFF">
+              <a:alpha val="0"/>
+            </a:srgbClr>
+          </a:solidFill>
           <a:ln w="28575">
             <a:solidFill>
               <a:srgbClr val="1E63D6"/>
@@ -4889,6 +4918,11 @@
               <a:gd name="adj" fmla="val 10724"/>
             </a:avLst>
           </a:prstGeom>
+          <a:solidFill>
+            <a:srgbClr val="FFFFFF">
+              <a:alpha val="0"/>
+            </a:srgbClr>
+          </a:solidFill>
           <a:ln w="28575">
             <a:solidFill>
               <a:srgbClr val="1E63D6"/>
@@ -4977,6 +5011,11 @@
               <a:gd name="adj" fmla="val 10724"/>
             </a:avLst>
           </a:prstGeom>
+          <a:solidFill>
+            <a:srgbClr val="FFFFFF">
+              <a:alpha val="0"/>
+            </a:srgbClr>
+          </a:solidFill>
           <a:ln w="28575">
             <a:solidFill>
               <a:srgbClr val="1E63D6"/>
@@ -5539,13 +5578,6 @@
           <a:prstGeom prst="rect">
             <a:avLst/>
           </a:prstGeom>
-          <a:effectLst>
-            <a:outerShdw sx="100000" sy="100000" kx="0" ky="0" algn="bl" rotWithShape="0" blurRad="76200" dist="25400" dir="5400000">
-              <a:srgbClr val="90A8BC">
-                <a:alpha val="35000"/>
-              </a:srgbClr>
-            </a:outerShdw>
-          </a:effectLst>
         </p:spPr>
       </p:pic>
       <p:sp>
@@ -5562,6 +5594,11 @@
           <a:prstGeom prst="RECTANGLE">
             <a:avLst/>
           </a:prstGeom>
+          <a:solidFill>
+            <a:srgbClr val="FFFFFF">
+              <a:alpha val="0"/>
+            </a:srgbClr>
+          </a:solidFill>
           <a:ln w="9525">
             <a:solidFill>
               <a:srgbClr val="C3D4E2"/>
@@ -5586,6 +5623,11 @@
               <a:gd name="adj" fmla="val 10724"/>
             </a:avLst>
           </a:prstGeom>
+          <a:solidFill>
+            <a:srgbClr val="FFFFFF">
+              <a:alpha val="0"/>
+            </a:srgbClr>
+          </a:solidFill>
           <a:ln w="28575">
             <a:solidFill>
               <a:srgbClr val="1E63D6"/>
@@ -5674,6 +5716,11 @@
               <a:gd name="adj" fmla="val 10724"/>
             </a:avLst>
           </a:prstGeom>
+          <a:solidFill>
+            <a:srgbClr val="FFFFFF">
+              <a:alpha val="0"/>
+            </a:srgbClr>
+          </a:solidFill>
           <a:ln w="28575">
             <a:solidFill>
               <a:srgbClr val="1E63D6"/>
@@ -5762,6 +5809,11 @@
               <a:gd name="adj" fmla="val 10724"/>
             </a:avLst>
           </a:prstGeom>
+          <a:solidFill>
+            <a:srgbClr val="FFFFFF">
+              <a:alpha val="0"/>
+            </a:srgbClr>
+          </a:solidFill>
           <a:ln w="28575">
             <a:solidFill>
               <a:srgbClr val="1E63D6"/>
@@ -6324,13 +6376,6 @@
           <a:prstGeom prst="rect">
             <a:avLst/>
           </a:prstGeom>
-          <a:effectLst>
-            <a:outerShdw sx="100000" sy="100000" kx="0" ky="0" algn="bl" rotWithShape="0" blurRad="76200" dist="25400" dir="5400000">
-              <a:srgbClr val="90A8BC">
-                <a:alpha val="35000"/>
-              </a:srgbClr>
-            </a:outerShdw>
-          </a:effectLst>
         </p:spPr>
       </p:pic>
       <p:sp>
@@ -6347,6 +6392,11 @@
           <a:prstGeom prst="RECTANGLE">
             <a:avLst/>
           </a:prstGeom>
+          <a:solidFill>
+            <a:srgbClr val="FFFFFF">
+              <a:alpha val="0"/>
+            </a:srgbClr>
+          </a:solidFill>
           <a:ln w="9525">
             <a:solidFill>
               <a:srgbClr val="C3D4E2"/>
@@ -6371,6 +6421,11 @@
               <a:gd name="adj" fmla="val 21120"/>
             </a:avLst>
           </a:prstGeom>
+          <a:solidFill>
+            <a:srgbClr val="FFFFFF">
+              <a:alpha val="0"/>
+            </a:srgbClr>
+          </a:solidFill>
           <a:ln w="28575">
             <a:solidFill>
               <a:srgbClr val="1E63D6"/>
@@ -6459,6 +6514,11 @@
               <a:gd name="adj" fmla="val 14361"/>
             </a:avLst>
           </a:prstGeom>
+          <a:solidFill>
+            <a:srgbClr val="FFFFFF">
+              <a:alpha val="0"/>
+            </a:srgbClr>
+          </a:solidFill>
           <a:ln w="28575">
             <a:solidFill>
               <a:srgbClr val="1E63D6"/>
@@ -6547,6 +6607,11 @@
               <a:gd name="adj" fmla="val 14361"/>
             </a:avLst>
           </a:prstGeom>
+          <a:solidFill>
+            <a:srgbClr val="FFFFFF">
+              <a:alpha val="0"/>
+            </a:srgbClr>
+          </a:solidFill>
           <a:ln w="28575">
             <a:solidFill>
               <a:srgbClr val="1E63D6"/>
@@ -7109,13 +7174,6 @@
           <a:prstGeom prst="rect">
             <a:avLst/>
           </a:prstGeom>
-          <a:effectLst>
-            <a:outerShdw sx="100000" sy="100000" kx="0" ky="0" algn="bl" rotWithShape="0" blurRad="76200" dist="25400" dir="5400000">
-              <a:srgbClr val="90A8BC">
-                <a:alpha val="35000"/>
-              </a:srgbClr>
-            </a:outerShdw>
-          </a:effectLst>
         </p:spPr>
       </p:pic>
       <p:sp>
@@ -7132,6 +7190,11 @@
           <a:prstGeom prst="RECTANGLE">
             <a:avLst/>
           </a:prstGeom>
+          <a:solidFill>
+            <a:srgbClr val="FFFFFF">
+              <a:alpha val="0"/>
+            </a:srgbClr>
+          </a:solidFill>
           <a:ln w="9525">
             <a:solidFill>
               <a:srgbClr val="C3D4E2"/>
@@ -7156,6 +7219,11 @@
               <a:gd name="adj" fmla="val 10941"/>
             </a:avLst>
           </a:prstGeom>
+          <a:solidFill>
+            <a:srgbClr val="FFFFFF">
+              <a:alpha val="0"/>
+            </a:srgbClr>
+          </a:solidFill>
           <a:ln w="28575">
             <a:solidFill>
               <a:srgbClr val="00A79D"/>
@@ -7490,13 +7558,6 @@
           <a:prstGeom prst="rect">
             <a:avLst/>
           </a:prstGeom>
-          <a:effectLst>
-            <a:outerShdw sx="100000" sy="100000" kx="0" ky="0" algn="bl" rotWithShape="0" blurRad="76200" dist="25400" dir="5400000">
-              <a:srgbClr val="90A8BC">
-                <a:alpha val="35000"/>
-              </a:srgbClr>
-            </a:outerShdw>
-          </a:effectLst>
         </p:spPr>
       </p:pic>
       <p:sp>
@@ -7513,6 +7574,11 @@
           <a:prstGeom prst="RECTANGLE">
             <a:avLst/>
           </a:prstGeom>
+          <a:solidFill>
+            <a:srgbClr val="FFFFFF">
+              <a:alpha val="0"/>
+            </a:srgbClr>
+          </a:solidFill>
           <a:ln w="9525">
             <a:solidFill>
               <a:srgbClr val="C3D4E2"/>
@@ -7537,6 +7603,11 @@
               <a:gd name="adj" fmla="val 16011"/>
             </a:avLst>
           </a:prstGeom>
+          <a:solidFill>
+            <a:srgbClr val="FFFFFF">
+              <a:alpha val="0"/>
+            </a:srgbClr>
+          </a:solidFill>
           <a:ln w="28575">
             <a:solidFill>
               <a:srgbClr val="1E63D6"/>
@@ -7625,6 +7696,11 @@
               <a:gd name="adj" fmla="val 16011"/>
             </a:avLst>
           </a:prstGeom>
+          <a:solidFill>
+            <a:srgbClr val="FFFFFF">
+              <a:alpha val="0"/>
+            </a:srgbClr>
+          </a:solidFill>
           <a:ln w="28575">
             <a:solidFill>
               <a:srgbClr val="1E63D6"/>
@@ -7713,6 +7789,11 @@
               <a:gd name="adj" fmla="val 9898"/>
             </a:avLst>
           </a:prstGeom>
+          <a:solidFill>
+            <a:srgbClr val="FFFFFF">
+              <a:alpha val="0"/>
+            </a:srgbClr>
+          </a:solidFill>
           <a:ln w="28575">
             <a:solidFill>
               <a:srgbClr val="1E63D6"/>

</xml_diff>